<commit_message>
Actualizar presentación con la última versión guardada
</commit_message>
<xml_diff>
--- a/TI.1.3. PAO202651_RESTFUL_JAVA_SINBDD_NRC36884_GR09/05. DOCUMENTACION/02. MANUAL TECNICO/MANUAL_RESTFUL_JAVA_SINBDD_GR09.pptx
+++ b/TI.1.3. PAO202651_RESTFUL_JAVA_SINBDD_NRC36884_GR09/05. DOCUMENTACION/02. MANUAL TECNICO/MANUAL_RESTFUL_JAVA_SINBDD_GR09.pptx
@@ -32086,7 +32086,7 @@
                 </a:solidFill>
                 <a:latin typeface="Arial" panose="020B0604020202020204" pitchFamily="34" charset="0"/>
               </a:rPr>
-              <a:t>Cliente SOAP/REST del móvil</a:t>
+              <a:t>Cliente HTTP/JSON del móvil</a:t>
             </a:r>
           </a:p>
         </p:txBody>
@@ -37381,7 +37381,7 @@
                 </a:solidFill>
                 <a:latin typeface="Arial" panose="020B0604020202020204" pitchFamily="34" charset="0"/>
               </a:rPr>
-              <a:t>Dependencias de servicios SOAP/REST</a:t>
+              <a:t>Dependencias Jersey y modelos JSON</a:t>
             </a:r>
           </a:p>
         </p:txBody>

</xml_diff>

<commit_message>
Actualizar manuales y presentaciones Java con las versiones actuales
</commit_message>
<xml_diff>
--- a/TI.1.3. PAO202651_RESTFUL_JAVA_SINBDD_NRC36884_GR09/05. DOCUMENTACION/02. MANUAL TECNICO/MANUAL_RESTFUL_JAVA_SINBDD_GR09.pptx
+++ b/TI.1.3. PAO202651_RESTFUL_JAVA_SINBDD_NRC36884_GR09/05. DOCUMENTACION/02. MANUAL TECNICO/MANUAL_RESTFUL_JAVA_SINBDD_GR09.pptx
@@ -296,7 +296,7 @@
       <p15:sldGuideLst xmlns:p15="http://schemas.microsoft.com/office/powerpoint/2012/main"/>
     </p:ext>
     <p:ext uri="GoogleSlidesCustomDataVersion2">
-      <go:slidesCustomData xmlns="" xmlns:mc="http://schemas.openxmlformats.org/markup-compatibility/2006" xmlns:mv="urn:schemas-microsoft-com:mac:vml" xmlns:c="http://schemas.openxmlformats.org/drawingml/2006/chart" xmlns:dgm="http://schemas.openxmlformats.org/drawingml/2006/diagram" xmlns:o="urn:schemas-microsoft-com:office:office" xmlns:v="urn:schemas-microsoft-com:vml" xmlns:pvml="urn:schemas-microsoft-com:office:powerpoint" xmlns:com="http://schemas.openxmlformats.org/drawingml/2006/compatibility" xmlns:p14="http://schemas.microsoft.com/office/powerpoint/2010/main" xmlns:p15="http://schemas.microsoft.com/office/powerpoint/2012/main" xmlns:ahyp="http://schemas.microsoft.com/office/drawing/2018/hyperlinkcolor" xmlns:go="http://customooxmlschemas.google.com/" r:id="rId55" roundtripDataSignature="AMtx7mhoWsaXMVBtv1HF1G3ccxKxe1iUlA=="/>
+      <go:slidesCustomData xmlns:go="http://customooxmlschemas.google.com/" xmlns:ahyp="http://schemas.microsoft.com/office/drawing/2018/hyperlinkcolor" xmlns:p15="http://schemas.microsoft.com/office/powerpoint/2012/main" xmlns:p14="http://schemas.microsoft.com/office/powerpoint/2010/main" xmlns:com="http://schemas.openxmlformats.org/drawingml/2006/compatibility" xmlns:pvml="urn:schemas-microsoft-com:office:powerpoint" xmlns:v="urn:schemas-microsoft-com:vml" xmlns:o="urn:schemas-microsoft-com:office:office" xmlns:dgm="http://schemas.openxmlformats.org/drawingml/2006/diagram" xmlns:c="http://schemas.openxmlformats.org/drawingml/2006/chart" xmlns:mv="urn:schemas-microsoft-com:mac:vml" xmlns:mc="http://schemas.openxmlformats.org/markup-compatibility/2006" xmlns="" r:id="rId55" roundtripDataSignature="AMtx7mhoWsaXMVBtv1HF1G3ccxKxe1iUlA=="/>
     </p:ext>
   </p:extLst>
 </p:presentation>
@@ -31947,7 +31947,7 @@
         </p:nvSpPr>
         <p:spPr>
           <a:xfrm>
-            <a:off x="4980331" y="3429000"/>
+            <a:off x="4980331" y="3710940"/>
             <a:ext cx="3802710" cy="2848362"/>
           </a:xfrm>
           <a:prstGeom prst="rect">
@@ -32017,7 +32017,7 @@
       </p:sp>
       <p:sp>
         <p:nvSpPr>
-          <p:cNvPr id="4" name="CAPTURA PENDIENTE - Cliente SOAP/REST del móvil">
+          <p:cNvPr id="4" name="CAPTURA PENDIENTE - Cliente HTTP JSON del móvil">
             <a:extLst>
               <a:ext uri="{FF2B5EF4-FFF2-40B4-BE49-F238E27FC236}">
                 <a16:creationId xmlns:a16="http://schemas.microsoft.com/office/drawing/2014/main" id="{E833F513-8033-4416-9E1E-E4BA1533EA86}"/>

</xml_diff>